<commit_message>
docs: add guide and roll number, remove the contribution slide
Both title slides now name the guide in full, Dr. M. Rupesh, Associate
Professor, EEE Department, and give Muskan's roll number, 23WH1A0208.

The Individual Contribution slide is removed from the first-review deck and
from its contents list, leaving 16 slides.
</commit_message>
<xml_diff>
--- a/docs/reviews/first-review/Predictive_BMS_First_Review.pptx
+++ b/docs/reviews/first-review/Predictive_BMS_First_Review.pptx
@@ -21,7 +21,6 @@
     <p:sldId id="269" r:id="rId21"/>
     <p:sldId id="270" r:id="rId22"/>
     <p:sldId id="271" r:id="rId23"/>
-    <p:sldId id="272" r:id="rId24"/>
   </p:sldIdLst>
   <p:sldSz cx="12191695" cy="6858000" type="screen4x3"/>
   <p:notesSz cx="6858000" cy="9144000"/>
@@ -883,22 +882,27 @@
           <a:lstStyle/>
           <a:p>
             <a:r>
-              <a:t>This is an individual project, so all of the work so far is mine. The main pieces are</a:t>
-            </a:r>
-          </a:p>
-          <a:p>
-            <a:r>
-              <a:t>the literature survey, the two-layer design, the component selection and costing, and a</a:t>
-            </a:r>
-          </a:p>
-          <a:p>
-            <a:r>
-              <a:t>staged build and test plan. That plan matters for safety: the lithium cells are only</a:t>
-            </a:r>
-          </a:p>
-          <a:p>
-            <a:r>
-              <a:t>connected after every sensor and both relays have been tested at low voltage.</a:t>
+              <a:t>This is where I am. The literature survey was done over the first two months, and the</a:t>
+            </a:r>
+          </a:p>
+          <a:p>
+            <a:r>
+              <a:t>two-layer design and component selection were finished in the second month. The</a:t>
+            </a:r>
+          </a:p>
+          <a:p>
+            <a:r>
+              <a:t>remaining three objectives are the build: assembling and calibrating the sensing</a:t>
+            </a:r>
+          </a:p>
+          <a:p>
+            <a:r>
+              <a:t>hardware, writing and testing the firmware, and then the dashboard, full testing and</a:t>
+            </a:r>
+          </a:p>
+          <a:p>
+            <a:r>
+              <a:t>documentation.</a:t>
             </a:r>
           </a:p>
         </p:txBody>
@@ -968,27 +972,7 @@
           <a:lstStyle/>
           <a:p>
             <a:r>
-              <a:t>This is where I am. The literature survey was done over the first two months, and the</a:t>
-            </a:r>
-          </a:p>
-          <a:p>
-            <a:r>
-              <a:t>two-layer design and component selection were finished in the second month. The</a:t>
-            </a:r>
-          </a:p>
-          <a:p>
-            <a:r>
-              <a:t>remaining three objectives are the build: assembling and calibrating the sensing</a:t>
-            </a:r>
-          </a:p>
-          <a:p>
-            <a:r>
-              <a:t>hardware, writing and testing the firmware, and then the dashboard, full testing and</a:t>
-            </a:r>
-          </a:p>
-          <a:p>
-            <a:r>
-              <a:t>documentation.</a:t>
+              <a:t>These are the first five references, in IEEE style, numbered as in the survey tables.</a:t>
             </a:r>
           </a:p>
         </p:txBody>
@@ -1058,7 +1042,7 @@
           <a:lstStyle/>
           <a:p>
             <a:r>
-              <a:t>These are the first five references, in IEEE style, numbered as in the survey tables.</a:t>
+              <a:t>These are references six to ten. Seven of the ten are IEEE publications.</a:t>
             </a:r>
           </a:p>
         </p:txBody>
@@ -1084,76 +1068,6 @@
 </file>
 
 <file path=ppt/notesSlides/notesSlide16.xml><?xml version="1.0" encoding="utf-8"?>
-<p:notes xmlns:a="http://schemas.openxmlformats.org/drawingml/2006/main" xmlns:p="http://schemas.openxmlformats.org/presentationml/2006/main" xmlns:r="http://schemas.openxmlformats.org/officeDocument/2006/relationships">
-  <p:cSld>
-    <p:spTree>
-      <p:nvGrpSpPr>
-        <p:cNvPr id="1" name=""/>
-        <p:cNvGrpSpPr/>
-        <p:nvPr/>
-      </p:nvGrpSpPr>
-      <p:grpSpPr>
-        <a:xfrm>
-          <a:off x="0" y="0"/>
-          <a:ext cx="0" cy="0"/>
-          <a:chOff x="0" y="0"/>
-          <a:chExt cx="0" cy="0"/>
-        </a:xfrm>
-      </p:grpSpPr>
-      <p:sp>
-        <p:nvSpPr>
-          <p:cNvPr id="2" name="Slide Image Placeholder 1"/>
-          <p:cNvSpPr>
-            <a:spLocks noGrp="1"/>
-          </p:cNvSpPr>
-          <p:nvPr>
-            <p:ph type="sldImg" idx="2"/>
-          </p:nvPr>
-        </p:nvSpPr>
-        <p:spPr/>
-      </p:sp>
-      <p:sp>
-        <p:nvSpPr>
-          <p:cNvPr id="3" name="Notes Placeholder 2"/>
-          <p:cNvSpPr>
-            <a:spLocks noGrp="1"/>
-          </p:cNvSpPr>
-          <p:nvPr>
-            <p:ph type="body" idx="3" sz="quarter"/>
-          </p:nvPr>
-        </p:nvSpPr>
-        <p:spPr/>
-        <p:txBody>
-          <a:bodyPr/>
-          <a:lstStyle/>
-          <a:p>
-            <a:r>
-              <a:t>These are references six to ten. Seven of the ten are IEEE publications.</a:t>
-            </a:r>
-          </a:p>
-        </p:txBody>
-      </p:sp>
-      <p:sp>
-        <p:nvSpPr>
-          <p:cNvPr id="4" name="Slide Number Placeholder 3"/>
-          <p:cNvSpPr>
-            <a:spLocks noGrp="1"/>
-          </p:cNvSpPr>
-          <p:nvPr>
-            <p:ph type="sldNum" idx="5" sz="quarter"/>
-          </p:nvPr>
-        </p:nvSpPr>
-        <p:spPr/>
-      </p:sp>
-    </p:spTree>
-  </p:cSld>
-  <p:clrMapOvr>
-    <a:masterClrMapping/>
-  </p:clrMapOvr>
-</p:notes>
-</file>
-
-<file path=ppt/notesSlides/notesSlide17.xml><?xml version="1.0" encoding="utf-8"?>
 <p:notes xmlns:a="http://schemas.openxmlformats.org/drawingml/2006/main" xmlns:p="http://schemas.openxmlformats.org/presentationml/2006/main" xmlns:r="http://schemas.openxmlformats.org/officeDocument/2006/relationships">
   <p:cSld>
     <p:spTree>
@@ -5228,7 +5142,7 @@
                 </a:solidFill>
                 <a:latin typeface="Times New Roman"/>
               </a:rPr>
-              <a:t>Roll No.  :  ____________</a:t>
+              <a:t>Roll No.  :  23WH1A0208</a:t>
             </a:r>
           </a:p>
         </p:txBody>
@@ -5284,7 +5198,7 @@
                 </a:solidFill>
                 <a:latin typeface="Times New Roman"/>
               </a:rPr>
-              <a:t>Rupesh</a:t>
+              <a:t>Dr. M. Rupesh</a:t>
             </a:r>
           </a:p>
           <a:p>
@@ -5295,7 +5209,18 @@
                 </a:solidFill>
                 <a:latin typeface="Times New Roman"/>
               </a:rPr>
-              <a:t>Department of EEE</a:t>
+              <a:t>Associate Professor</a:t>
+            </a:r>
+          </a:p>
+          <a:p>
+            <a:r>
+              <a:rPr sz="1800" b="0" i="0" u="none">
+                <a:solidFill>
+                  <a:srgbClr val="000000"/>
+                </a:solidFill>
+                <a:latin typeface="Times New Roman"/>
+              </a:rPr>
+              <a:t>EEE Department</a:t>
             </a:r>
           </a:p>
           <a:p>
@@ -6994,7 +6919,7 @@
                 </a:solidFill>
                 <a:latin typeface="Times New Roman"/>
               </a:rPr>
-              <a:t>Individual Contribution</a:t>
+              <a:t>Project Timeline</a:t>
             </a:r>
           </a:p>
         </p:txBody>
@@ -7099,513 +7024,6 @@
                 <a:latin typeface="Calibri"/>
               </a:rPr>
               <a:t>13</a:t>
-            </a:r>
-          </a:p>
-        </p:txBody>
-      </p:sp>
-      <p:graphicFrame>
-        <p:nvGraphicFramePr>
-          <p:cNvPr id="7" name="Table 6"/>
-          <p:cNvGraphicFramePr>
-            <a:graphicFrameLocks noGrp="1"/>
-          </p:cNvGraphicFramePr>
-          <p:nvPr/>
-        </p:nvGraphicFramePr>
-        <p:xfrm>
-          <a:off x="746607" y="1389888"/>
-          <a:ext cx="10698480" cy="4389120"/>
-        </p:xfrm>
-        <a:graphic>
-          <a:graphicData uri="http://schemas.openxmlformats.org/drawingml/2006/table">
-            <a:tbl>
-              <a:tblPr firstRow="1">
-                <a:tableStyleId>{5C22544A-7EE6-4342-B048-85BDC9FD1C3A}</a:tableStyleId>
-              </a:tblPr>
-              <a:tblGrid>
-                <a:gridCol w="3017520"/>
-                <a:gridCol w="7680960"/>
-              </a:tblGrid>
-              <a:tr h="731520">
-                <a:tc>
-                  <a:txBody>
-                    <a:bodyPr/>
-                    <a:lstStyle/>
-                    <a:p>
-                      <a:pPr algn="ctr"/>
-                      <a:r>
-                        <a:rPr sz="1500" b="1" i="0" u="none">
-                          <a:solidFill>
-                            <a:srgbClr val="FFFFFF"/>
-                          </a:solidFill>
-                          <a:latin typeface="Times New Roman"/>
-                        </a:rPr>
-                        <a:t>Member</a:t>
-                      </a:r>
-                    </a:p>
-                  </a:txBody>
-                  <a:tcPr anchor="ctr" marL="64008" marR="64008">
-                    <a:solidFill>
-                      <a:srgbClr val="002060"/>
-                    </a:solidFill>
-                  </a:tcPr>
-                </a:tc>
-                <a:tc>
-                  <a:txBody>
-                    <a:bodyPr/>
-                    <a:lstStyle/>
-                    <a:p>
-                      <a:pPr algn="ctr"/>
-                      <a:r>
-                        <a:rPr sz="1500" b="1" i="0" u="none">
-                          <a:solidFill>
-                            <a:srgbClr val="FFFFFF"/>
-                          </a:solidFill>
-                          <a:latin typeface="Times New Roman"/>
-                        </a:rPr>
-                        <a:t>Contributions</a:t>
-                      </a:r>
-                    </a:p>
-                  </a:txBody>
-                  <a:tcPr anchor="ctr" marL="64008" marR="64008">
-                    <a:solidFill>
-                      <a:srgbClr val="002060"/>
-                    </a:solidFill>
-                  </a:tcPr>
-                </a:tc>
-              </a:tr>
-              <a:tr h="731520">
-                <a:tc rowSpan="5">
-                  <a:txBody>
-                    <a:bodyPr/>
-                    <a:lstStyle/>
-                    <a:p>
-                      <a:pPr algn="ctr"/>
-                      <a:r>
-                        <a:rPr sz="1500" b="0" i="0" u="none">
-                          <a:solidFill>
-                            <a:srgbClr val="000000"/>
-                          </a:solidFill>
-                          <a:latin typeface="Times New Roman"/>
-                        </a:rPr>
-                        <a:t>Ms. Muskan Sulathana</a:t>
-                      </a:r>
-                    </a:p>
-                    <a:p>
-                      <a:pPr algn="ctr"/>
-                      <a:r>
-                        <a:rPr sz="1500" b="0" i="0" u="none">
-                          <a:solidFill>
-                            <a:srgbClr val="000000"/>
-                          </a:solidFill>
-                          <a:latin typeface="Times New Roman"/>
-                        </a:rPr>
-                        <a:t>(individual project)</a:t>
-                      </a:r>
-                    </a:p>
-                  </a:txBody>
-                  <a:tcPr anchor="ctr" marL="64008" marR="64008" marT="27432" marB="27432">
-                    <a:solidFill>
-                      <a:srgbClr val="FFFFFF"/>
-                    </a:solidFill>
-                  </a:tcPr>
-                </a:tc>
-                <a:tc>
-                  <a:txBody>
-                    <a:bodyPr/>
-                    <a:lstStyle/>
-                    <a:p>
-                      <a:pPr algn="l"/>
-                      <a:r>
-                        <a:rPr sz="1500" b="0" i="0" u="none">
-                          <a:solidFill>
-                            <a:srgbClr val="000000"/>
-                          </a:solidFill>
-                          <a:latin typeface="Times New Roman"/>
-                        </a:rPr>
-                        <a:t>Studied research papers on thermal runaway, early-warning methods and BMS design, and identified the research gap.</a:t>
-                      </a:r>
-                    </a:p>
-                  </a:txBody>
-                  <a:tcPr anchor="ctr" marL="64008" marR="64008" marT="27432" marB="27432">
-                    <a:solidFill>
-                      <a:srgbClr val="FFFFFF"/>
-                    </a:solidFill>
-                  </a:tcPr>
-                </a:tc>
-              </a:tr>
-              <a:tr h="731520">
-                <a:tc vMerge="1">
-                  <a:txBody>
-                    <a:bodyPr/>
-                    <a:lstStyle/>
-                    <a:p>
-                      <a:pPr algn="ctr"/>
-                      <a:r>
-                        <a:rPr sz="1500" b="0" i="0" u="none">
-                          <a:solidFill>
-                            <a:srgbClr val="000000"/>
-                          </a:solidFill>
-                          <a:latin typeface="Times New Roman"/>
-                        </a:rPr>
-                        <a:t/>
-                      </a:r>
-                    </a:p>
-                  </a:txBody>
-                  <a:tcPr anchor="ctr" marL="64008" marR="64008" marT="27432" marB="27432">
-                    <a:solidFill>
-                      <a:srgbClr val="EDEDED"/>
-                    </a:solidFill>
-                  </a:tcPr>
-                </a:tc>
-                <a:tc>
-                  <a:txBody>
-                    <a:bodyPr/>
-                    <a:lstStyle/>
-                    <a:p>
-                      <a:pPr algn="l"/>
-                      <a:r>
-                        <a:rPr sz="1500" b="0" i="0" u="none">
-                          <a:solidFill>
-                            <a:srgbClr val="000000"/>
-                          </a:solidFill>
-                          <a:latin typeface="Times New Roman"/>
-                        </a:rPr>
-                        <a:t>Designed the two-layer protection: an independent hardware BMS and an ESP32 supervisor with separate charge and load relays.</a:t>
-                      </a:r>
-                    </a:p>
-                  </a:txBody>
-                  <a:tcPr anchor="ctr" marL="64008" marR="64008" marT="27432" marB="27432">
-                    <a:solidFill>
-                      <a:srgbClr val="EDEDED"/>
-                    </a:solidFill>
-                  </a:tcPr>
-                </a:tc>
-              </a:tr>
-              <a:tr h="731520">
-                <a:tc vMerge="1">
-                  <a:txBody>
-                    <a:bodyPr/>
-                    <a:lstStyle/>
-                    <a:p>
-                      <a:pPr algn="ctr"/>
-                      <a:r>
-                        <a:rPr sz="1500" b="0" i="0" u="none">
-                          <a:solidFill>
-                            <a:srgbClr val="000000"/>
-                          </a:solidFill>
-                          <a:latin typeface="Times New Roman"/>
-                        </a:rPr>
-                        <a:t/>
-                      </a:r>
-                    </a:p>
-                  </a:txBody>
-                  <a:tcPr anchor="ctr" marL="64008" marR="64008" marT="27432" marB="27432">
-                    <a:solidFill>
-                      <a:srgbClr val="FFFFFF"/>
-                    </a:solidFill>
-                  </a:tcPr>
-                </a:tc>
-                <a:tc>
-                  <a:txBody>
-                    <a:bodyPr/>
-                    <a:lstStyle/>
-                    <a:p>
-                      <a:pPr algn="l"/>
-                      <a:r>
-                        <a:rPr sz="1500" b="0" i="0" u="none">
-                          <a:solidFill>
-                            <a:srgbClr val="000000"/>
-                          </a:solidFill>
-                          <a:latin typeface="Times New Roman"/>
-                        </a:rPr>
-                        <a:t>Selected and costed every component, reconciled the purchase list and recorded the parts already in hand.</a:t>
-                      </a:r>
-                    </a:p>
-                  </a:txBody>
-                  <a:tcPr anchor="ctr" marL="64008" marR="64008" marT="27432" marB="27432">
-                    <a:solidFill>
-                      <a:srgbClr val="FFFFFF"/>
-                    </a:solidFill>
-                  </a:tcPr>
-                </a:tc>
-              </a:tr>
-              <a:tr h="731520">
-                <a:tc vMerge="1">
-                  <a:txBody>
-                    <a:bodyPr/>
-                    <a:lstStyle/>
-                    <a:p>
-                      <a:pPr algn="ctr"/>
-                      <a:r>
-                        <a:rPr sz="1500" b="0" i="0" u="none">
-                          <a:solidFill>
-                            <a:srgbClr val="000000"/>
-                          </a:solidFill>
-                          <a:latin typeface="Times New Roman"/>
-                        </a:rPr>
-                        <a:t/>
-                      </a:r>
-                    </a:p>
-                  </a:txBody>
-                  <a:tcPr anchor="ctr" marL="64008" marR="64008" marT="27432" marB="27432">
-                    <a:solidFill>
-                      <a:srgbClr val="EDEDED"/>
-                    </a:solidFill>
-                  </a:tcPr>
-                </a:tc>
-                <a:tc>
-                  <a:txBody>
-                    <a:bodyPr/>
-                    <a:lstStyle/>
-                    <a:p>
-                      <a:pPr algn="l"/>
-                      <a:r>
-                        <a:rPr sz="1500" b="0" i="0" u="none">
-                          <a:solidFill>
-                            <a:srgbClr val="000000"/>
-                          </a:solidFill>
-                          <a:latin typeface="Times New Roman"/>
-                        </a:rPr>
-                        <a:t>Prepared a twelve-stage build and test plan, in which the cells are added only after low-voltage testing.</a:t>
-                      </a:r>
-                    </a:p>
-                  </a:txBody>
-                  <a:tcPr anchor="ctr" marL="64008" marR="64008" marT="27432" marB="27432">
-                    <a:solidFill>
-                      <a:srgbClr val="EDEDED"/>
-                    </a:solidFill>
-                  </a:tcPr>
-                </a:tc>
-              </a:tr>
-              <a:tr h="731520">
-                <a:tc vMerge="1">
-                  <a:txBody>
-                    <a:bodyPr/>
-                    <a:lstStyle/>
-                    <a:p>
-                      <a:pPr algn="ctr"/>
-                      <a:r>
-                        <a:rPr sz="1500" b="0" i="0" u="none">
-                          <a:solidFill>
-                            <a:srgbClr val="000000"/>
-                          </a:solidFill>
-                          <a:latin typeface="Times New Roman"/>
-                        </a:rPr>
-                        <a:t/>
-                      </a:r>
-                    </a:p>
-                  </a:txBody>
-                  <a:tcPr anchor="ctr" marL="64008" marR="64008" marT="27432" marB="27432">
-                    <a:solidFill>
-                      <a:srgbClr val="FFFFFF"/>
-                    </a:solidFill>
-                  </a:tcPr>
-                </a:tc>
-                <a:tc>
-                  <a:txBody>
-                    <a:bodyPr/>
-                    <a:lstStyle/>
-                    <a:p>
-                      <a:pPr algn="l"/>
-                      <a:r>
-                        <a:rPr sz="1500" b="0" i="0" u="none">
-                          <a:solidFill>
-                            <a:srgbClr val="000000"/>
-                          </a:solidFill>
-                          <a:latin typeface="Times New Roman"/>
-                        </a:rPr>
-                        <a:t>Prepared the project documents and this presentation.</a:t>
-                      </a:r>
-                    </a:p>
-                  </a:txBody>
-                  <a:tcPr anchor="ctr" marL="64008" marR="64008" marT="27432" marB="27432">
-                    <a:solidFill>
-                      <a:srgbClr val="FFFFFF"/>
-                    </a:solidFill>
-                  </a:tcPr>
-                </a:tc>
-              </a:tr>
-            </a:tbl>
-          </a:graphicData>
-        </a:graphic>
-      </p:graphicFrame>
-    </p:spTree>
-  </p:cSld>
-  <p:clrMapOvr>
-    <a:masterClrMapping/>
-  </p:clrMapOvr>
-</p:sld>
-</file>
-
-<file path=ppt/slides/slide14.xml><?xml version="1.0" encoding="utf-8"?>
-<p:sld xmlns:a="http://schemas.openxmlformats.org/drawingml/2006/main" xmlns:p="http://schemas.openxmlformats.org/presentationml/2006/main" xmlns:r="http://schemas.openxmlformats.org/officeDocument/2006/relationships">
-  <p:cSld>
-    <p:spTree>
-      <p:nvGrpSpPr>
-        <p:cNvPr id="1" name=""/>
-        <p:cNvGrpSpPr/>
-        <p:nvPr/>
-      </p:nvGrpSpPr>
-      <p:grpSpPr/>
-      <p:pic>
-        <p:nvPicPr>
-          <p:cNvPr id="2" name="Picture 1" descr="logo.png"/>
-          <p:cNvPicPr>
-            <a:picLocks noChangeAspect="1"/>
-          </p:cNvPicPr>
-          <p:nvPr/>
-        </p:nvPicPr>
-        <p:blipFill>
-          <a:blip r:embed="rId2"/>
-          <a:stretch>
-            <a:fillRect/>
-          </a:stretch>
-        </p:blipFill>
-        <p:spPr>
-          <a:xfrm>
-            <a:off x="286207" y="109728"/>
-            <a:ext cx="646480" cy="950976"/>
-          </a:xfrm>
-          <a:prstGeom prst="rect">
-            <a:avLst/>
-          </a:prstGeom>
-        </p:spPr>
-      </p:pic>
-      <p:sp>
-        <p:nvSpPr>
-          <p:cNvPr id="3" name="TextBox 2"/>
-          <p:cNvSpPr txBox="1"/>
-          <p:nvPr/>
-        </p:nvSpPr>
-        <p:spPr>
-          <a:xfrm>
-            <a:off x="1188720" y="384048"/>
-            <a:ext cx="9814255" cy="548640"/>
-          </a:xfrm>
-          <a:prstGeom prst="rect">
-            <a:avLst/>
-          </a:prstGeom>
-          <a:noFill/>
-        </p:spPr>
-        <p:txBody>
-          <a:bodyPr wrap="square" lIns="0" rIns="0" tIns="0" bIns="0">
-            <a:noAutofit/>
-          </a:bodyPr>
-          <a:lstStyle/>
-          <a:p>
-            <a:pPr algn="ctr"/>
-            <a:r>
-              <a:rPr sz="2400" b="1" i="0" u="sng">
-                <a:solidFill>
-                  <a:srgbClr val="000000"/>
-                </a:solidFill>
-                <a:latin typeface="Times New Roman"/>
-              </a:rPr>
-              <a:t>Project Timeline</a:t>
-            </a:r>
-          </a:p>
-        </p:txBody>
-      </p:sp>
-      <p:sp>
-        <p:nvSpPr>
-          <p:cNvPr id="4" name="TextBox 3"/>
-          <p:cNvSpPr txBox="1"/>
-          <p:nvPr/>
-        </p:nvSpPr>
-        <p:spPr>
-          <a:xfrm>
-            <a:off x="929944" y="6355080"/>
-            <a:ext cx="2286000" cy="292608"/>
-          </a:xfrm>
-          <a:prstGeom prst="rect">
-            <a:avLst/>
-          </a:prstGeom>
-          <a:noFill/>
-        </p:spPr>
-        <p:txBody>
-          <a:bodyPr wrap="square" lIns="0" rIns="0" tIns="0" bIns="0">
-            <a:noAutofit/>
-          </a:bodyPr>
-          <a:lstStyle/>
-          <a:p>
-            <a:r>
-              <a:rPr sz="1200" b="0" i="0" u="none">
-                <a:solidFill>
-                  <a:srgbClr val="898989"/>
-                </a:solidFill>
-                <a:latin typeface="Calibri"/>
-              </a:rPr>
-              <a:t>29-09-2026</a:t>
-            </a:r>
-          </a:p>
-        </p:txBody>
-      </p:sp>
-      <p:sp>
-        <p:nvSpPr>
-          <p:cNvPr id="5" name="TextBox 4"/>
-          <p:cNvSpPr txBox="1"/>
-          <p:nvPr/>
-        </p:nvSpPr>
-        <p:spPr>
-          <a:xfrm>
-            <a:off x="3931920" y="6355080"/>
-            <a:ext cx="4297680" cy="292608"/>
-          </a:xfrm>
-          <a:prstGeom prst="rect">
-            <a:avLst/>
-          </a:prstGeom>
-          <a:noFill/>
-        </p:spPr>
-        <p:txBody>
-          <a:bodyPr wrap="square" lIns="0" rIns="0" tIns="0" bIns="0">
-            <a:noAutofit/>
-          </a:bodyPr>
-          <a:lstStyle/>
-          <a:p>
-            <a:pPr algn="ctr"/>
-            <a:r>
-              <a:rPr sz="1200" b="0" i="0" u="none">
-                <a:solidFill>
-                  <a:srgbClr val="898989"/>
-                </a:solidFill>
-                <a:latin typeface="Calibri"/>
-              </a:rPr>
-              <a:t>First Review-2026-27</a:t>
-            </a:r>
-          </a:p>
-        </p:txBody>
-      </p:sp>
-      <p:sp>
-        <p:nvSpPr>
-          <p:cNvPr id="6" name="TextBox 5"/>
-          <p:cNvSpPr txBox="1"/>
-          <p:nvPr/>
-        </p:nvSpPr>
-        <p:spPr>
-          <a:xfrm>
-            <a:off x="10058400" y="6355080"/>
-            <a:ext cx="1204264" cy="292608"/>
-          </a:xfrm>
-          <a:prstGeom prst="rect">
-            <a:avLst/>
-          </a:prstGeom>
-          <a:noFill/>
-        </p:spPr>
-        <p:txBody>
-          <a:bodyPr wrap="square" lIns="0" rIns="0" tIns="0" bIns="0">
-            <a:noAutofit/>
-          </a:bodyPr>
-          <a:lstStyle/>
-          <a:p>
-            <a:pPr algn="r"/>
-            <a:r>
-              <a:rPr sz="1200" b="0" i="0" u="none">
-                <a:solidFill>
-                  <a:srgbClr val="898989"/>
-                </a:solidFill>
-                <a:latin typeface="Calibri"/>
-              </a:rPr>
-              <a:t>14</a:t>
             </a:r>
           </a:p>
         </p:txBody>
@@ -8580,6 +7998,355 @@
 </p:sld>
 </file>
 
+<file path=ppt/slides/slide14.xml><?xml version="1.0" encoding="utf-8"?>
+<p:sld xmlns:a="http://schemas.openxmlformats.org/drawingml/2006/main" xmlns:p="http://schemas.openxmlformats.org/presentationml/2006/main" xmlns:r="http://schemas.openxmlformats.org/officeDocument/2006/relationships">
+  <p:cSld>
+    <p:spTree>
+      <p:nvGrpSpPr>
+        <p:cNvPr id="1" name=""/>
+        <p:cNvGrpSpPr/>
+        <p:nvPr/>
+      </p:nvGrpSpPr>
+      <p:grpSpPr/>
+      <p:pic>
+        <p:nvPicPr>
+          <p:cNvPr id="2" name="Picture 1" descr="logo.png"/>
+          <p:cNvPicPr>
+            <a:picLocks noChangeAspect="1"/>
+          </p:cNvPicPr>
+          <p:nvPr/>
+        </p:nvPicPr>
+        <p:blipFill>
+          <a:blip r:embed="rId2"/>
+          <a:stretch>
+            <a:fillRect/>
+          </a:stretch>
+        </p:blipFill>
+        <p:spPr>
+          <a:xfrm>
+            <a:off x="286207" y="109728"/>
+            <a:ext cx="646480" cy="950976"/>
+          </a:xfrm>
+          <a:prstGeom prst="rect">
+            <a:avLst/>
+          </a:prstGeom>
+        </p:spPr>
+      </p:pic>
+      <p:sp>
+        <p:nvSpPr>
+          <p:cNvPr id="3" name="TextBox 2"/>
+          <p:cNvSpPr txBox="1"/>
+          <p:nvPr/>
+        </p:nvSpPr>
+        <p:spPr>
+          <a:xfrm>
+            <a:off x="1188720" y="384048"/>
+            <a:ext cx="9814255" cy="548640"/>
+          </a:xfrm>
+          <a:prstGeom prst="rect">
+            <a:avLst/>
+          </a:prstGeom>
+          <a:noFill/>
+        </p:spPr>
+        <p:txBody>
+          <a:bodyPr wrap="square" lIns="0" rIns="0" tIns="0" bIns="0">
+            <a:noAutofit/>
+          </a:bodyPr>
+          <a:lstStyle/>
+          <a:p>
+            <a:pPr algn="ctr"/>
+            <a:r>
+              <a:rPr sz="2400" b="1" i="0" u="sng">
+                <a:solidFill>
+                  <a:srgbClr val="000000"/>
+                </a:solidFill>
+                <a:latin typeface="Times New Roman"/>
+              </a:rPr>
+              <a:t>References</a:t>
+            </a:r>
+          </a:p>
+        </p:txBody>
+      </p:sp>
+      <p:sp>
+        <p:nvSpPr>
+          <p:cNvPr id="4" name="TextBox 3"/>
+          <p:cNvSpPr txBox="1"/>
+          <p:nvPr/>
+        </p:nvSpPr>
+        <p:spPr>
+          <a:xfrm>
+            <a:off x="929944" y="6355080"/>
+            <a:ext cx="2286000" cy="292608"/>
+          </a:xfrm>
+          <a:prstGeom prst="rect">
+            <a:avLst/>
+          </a:prstGeom>
+          <a:noFill/>
+        </p:spPr>
+        <p:txBody>
+          <a:bodyPr wrap="square" lIns="0" rIns="0" tIns="0" bIns="0">
+            <a:noAutofit/>
+          </a:bodyPr>
+          <a:lstStyle/>
+          <a:p>
+            <a:r>
+              <a:rPr sz="1200" b="0" i="0" u="none">
+                <a:solidFill>
+                  <a:srgbClr val="898989"/>
+                </a:solidFill>
+                <a:latin typeface="Calibri"/>
+              </a:rPr>
+              <a:t>29-09-2026</a:t>
+            </a:r>
+          </a:p>
+        </p:txBody>
+      </p:sp>
+      <p:sp>
+        <p:nvSpPr>
+          <p:cNvPr id="5" name="TextBox 4"/>
+          <p:cNvSpPr txBox="1"/>
+          <p:nvPr/>
+        </p:nvSpPr>
+        <p:spPr>
+          <a:xfrm>
+            <a:off x="3931920" y="6355080"/>
+            <a:ext cx="4297680" cy="292608"/>
+          </a:xfrm>
+          <a:prstGeom prst="rect">
+            <a:avLst/>
+          </a:prstGeom>
+          <a:noFill/>
+        </p:spPr>
+        <p:txBody>
+          <a:bodyPr wrap="square" lIns="0" rIns="0" tIns="0" bIns="0">
+            <a:noAutofit/>
+          </a:bodyPr>
+          <a:lstStyle/>
+          <a:p>
+            <a:pPr algn="ctr"/>
+            <a:r>
+              <a:rPr sz="1200" b="0" i="0" u="none">
+                <a:solidFill>
+                  <a:srgbClr val="898989"/>
+                </a:solidFill>
+                <a:latin typeface="Calibri"/>
+              </a:rPr>
+              <a:t>First Review-2026-27</a:t>
+            </a:r>
+          </a:p>
+        </p:txBody>
+      </p:sp>
+      <p:sp>
+        <p:nvSpPr>
+          <p:cNvPr id="6" name="TextBox 5"/>
+          <p:cNvSpPr txBox="1"/>
+          <p:nvPr/>
+        </p:nvSpPr>
+        <p:spPr>
+          <a:xfrm>
+            <a:off x="10058400" y="6355080"/>
+            <a:ext cx="1204264" cy="292608"/>
+          </a:xfrm>
+          <a:prstGeom prst="rect">
+            <a:avLst/>
+          </a:prstGeom>
+          <a:noFill/>
+        </p:spPr>
+        <p:txBody>
+          <a:bodyPr wrap="square" lIns="0" rIns="0" tIns="0" bIns="0">
+            <a:noAutofit/>
+          </a:bodyPr>
+          <a:lstStyle/>
+          <a:p>
+            <a:pPr algn="r"/>
+            <a:r>
+              <a:rPr sz="1200" b="0" i="0" u="none">
+                <a:solidFill>
+                  <a:srgbClr val="898989"/>
+                </a:solidFill>
+                <a:latin typeface="Calibri"/>
+              </a:rPr>
+              <a:t>14</a:t>
+            </a:r>
+          </a:p>
+        </p:txBody>
+      </p:sp>
+      <p:sp>
+        <p:nvSpPr>
+          <p:cNvPr id="7" name="TextBox 6"/>
+          <p:cNvSpPr txBox="1"/>
+          <p:nvPr/>
+        </p:nvSpPr>
+        <p:spPr>
+          <a:xfrm>
+            <a:off x="1168603" y="1389888"/>
+            <a:ext cx="10195560" cy="4754879"/>
+          </a:xfrm>
+          <a:prstGeom prst="rect">
+            <a:avLst/>
+          </a:prstGeom>
+          <a:noFill/>
+        </p:spPr>
+        <p:txBody>
+          <a:bodyPr wrap="square" lIns="0" rIns="0" tIns="0" bIns="0">
+            <a:noAutofit/>
+          </a:bodyPr>
+          <a:lstStyle/>
+          <a:p>
+            <a:pPr marL="384048" indent="-384048">
+              <a:lnSpc>
+                <a:spcPct val="110000"/>
+              </a:lnSpc>
+              <a:spcAft>
+                <a:spcPts val="2000"/>
+              </a:spcAft>
+              <a:buNone/>
+            </a:pPr>
+            <a:r>
+              <a:rPr sz="1400" b="0" i="0" u="none">
+                <a:solidFill>
+                  <a:srgbClr val="000000"/>
+                </a:solidFill>
+                <a:latin typeface="Times New Roman"/>
+              </a:rPr>
+              <a:t>[1]  </a:t>
+            </a:r>
+            <a:r>
+              <a:rPr sz="1400" b="0" i="0" u="none">
+                <a:solidFill>
+                  <a:srgbClr val="000000"/>
+                </a:solidFill>
+                <a:latin typeface="Times New Roman"/>
+              </a:rPr>
+              <a:t>X. Feng, M. Ouyang, X. Liu, L. Lu, Y. Xia, and X. He, “Thermal runaway mechanism of lithium ion battery for electric vehicles: A review,” Energy Storage Mater., vol. 10, pp. 246–267, Jan. 2018, doi: 10.1016/j.ensm.2017.05.013.</a:t>
+            </a:r>
+          </a:p>
+          <a:p>
+            <a:pPr marL="384048" indent="-384048">
+              <a:lnSpc>
+                <a:spcPct val="110000"/>
+              </a:lnSpc>
+              <a:spcAft>
+                <a:spcPts val="2000"/>
+              </a:spcAft>
+              <a:buNone/>
+            </a:pPr>
+            <a:r>
+              <a:rPr sz="1400" b="0" i="0" u="none">
+                <a:solidFill>
+                  <a:srgbClr val="000000"/>
+                </a:solidFill>
+                <a:latin typeface="Times New Roman"/>
+              </a:rPr>
+              <a:t>[2]  </a:t>
+            </a:r>
+            <a:r>
+              <a:rPr sz="1400" b="0" i="0" u="none">
+                <a:solidFill>
+                  <a:srgbClr val="000000"/>
+                </a:solidFill>
+                <a:latin typeface="Times New Roman"/>
+              </a:rPr>
+              <a:t>H. Rahimi-Eichi, U. Ojha, F. Baronti, and M.-Y. Chow, “Battery management system: An overview of its application in the smart grid and electric vehicles,” IEEE Ind. Electron. Mag., vol. 7, no. 2, pp. 4–16, Jun. 2013, doi: 10.1109/MIE.2013.2250351.</a:t>
+            </a:r>
+          </a:p>
+          <a:p>
+            <a:pPr marL="384048" indent="-384048">
+              <a:lnSpc>
+                <a:spcPct val="110000"/>
+              </a:lnSpc>
+              <a:spcAft>
+                <a:spcPts val="2000"/>
+              </a:spcAft>
+              <a:buNone/>
+            </a:pPr>
+            <a:r>
+              <a:rPr sz="1400" b="0" i="0" u="none">
+                <a:solidFill>
+                  <a:srgbClr val="000000"/>
+                </a:solidFill>
+                <a:latin typeface="Times New Roman"/>
+              </a:rPr>
+              <a:t>[3]  </a:t>
+            </a:r>
+            <a:r>
+              <a:rPr sz="1400" b="0" i="0" u="none">
+                <a:solidFill>
+                  <a:srgbClr val="000000"/>
+                </a:solidFill>
+                <a:latin typeface="Times New Roman"/>
+              </a:rPr>
+              <a:t>B. Xu, L. Kong, G. Wen, and M. G. Pecht, “Protection devices in commercial 18650 lithium-ion batteries,” IEEE Access, vol. 9, pp. 66687–66695, 2021, doi: 10.1109/ACCESS.2021.3075972.</a:t>
+            </a:r>
+          </a:p>
+          <a:p>
+            <a:pPr marL="384048" indent="-384048">
+              <a:lnSpc>
+                <a:spcPct val="110000"/>
+              </a:lnSpc>
+              <a:spcAft>
+                <a:spcPts val="2000"/>
+              </a:spcAft>
+              <a:buNone/>
+            </a:pPr>
+            <a:r>
+              <a:rPr sz="1400" b="0" i="0" u="none">
+                <a:solidFill>
+                  <a:srgbClr val="000000"/>
+                </a:solidFill>
+                <a:latin typeface="Times New Roman"/>
+              </a:rPr>
+              <a:t>[4]  </a:t>
+            </a:r>
+            <a:r>
+              <a:rPr sz="1400" b="0" i="0" u="none">
+                <a:solidFill>
+                  <a:srgbClr val="000000"/>
+                </a:solidFill>
+                <a:latin typeface="Times New Roman"/>
+              </a:rPr>
+              <a:t>X. Hu, K. Zhang, K. Liu, X. Lin, S. Dey, and S. Onori, “Advanced fault diagnosis for lithium-ion battery systems: A review of fault mechanisms, fault features, and diagnosis procedures,” IEEE Ind. Electron. Mag., vol. 14, no. 3, pp. 65–91, Sep. 2020, doi: 10.1109/MIE.2020.2964814.</a:t>
+            </a:r>
+          </a:p>
+          <a:p>
+            <a:pPr marL="384048" indent="-384048">
+              <a:lnSpc>
+                <a:spcPct val="110000"/>
+              </a:lnSpc>
+              <a:spcAft>
+                <a:spcPts val="2000"/>
+              </a:spcAft>
+              <a:buNone/>
+            </a:pPr>
+            <a:r>
+              <a:rPr sz="1400" b="0" i="0" u="none">
+                <a:solidFill>
+                  <a:srgbClr val="000000"/>
+                </a:solidFill>
+                <a:latin typeface="Times New Roman"/>
+              </a:rPr>
+              <a:t>[5]  </a:t>
+            </a:r>
+            <a:r>
+              <a:rPr sz="1400" b="0" i="0" u="none">
+                <a:solidFill>
+                  <a:srgbClr val="000000"/>
+                </a:solidFill>
+                <a:latin typeface="Times New Roman"/>
+              </a:rPr>
+              <a:t>X. Zhang, S. Chen, J. Zhu, and Y. Gao, “A critical review of thermal runaway prediction and early-warning methods for lithium-ion batteries,” Energy Mater. Adv., vol. 4, Art. no. 0008, 2023, doi: 10.34133/energymatadv.0008.</a:t>
+            </a:r>
+          </a:p>
+        </p:txBody>
+      </p:sp>
+    </p:spTree>
+  </p:cSld>
+  <p:clrMapOvr>
+    <a:masterClrMapping/>
+  </p:clrMapOvr>
+</p:sld>
+</file>
+
 <file path=ppt/slides/slide15.xml><?xml version="1.0" encoding="utf-8"?>
 <p:sld xmlns:a="http://schemas.openxmlformats.org/drawingml/2006/main" xmlns:p="http://schemas.openxmlformats.org/presentationml/2006/main" xmlns:r="http://schemas.openxmlformats.org/officeDocument/2006/relationships">
   <p:cSld>
@@ -8644,7 +8411,7 @@
                 </a:solidFill>
                 <a:latin typeface="Times New Roman"/>
               </a:rPr>
-              <a:t>References</a:t>
+              <a:t>References (contd.)</a:t>
             </a:r>
           </a:p>
         </p:txBody>
@@ -8791,7 +8558,7 @@
                 </a:solidFill>
                 <a:latin typeface="Times New Roman"/>
               </a:rPr>
-              <a:t>[1]  </a:t>
+              <a:t>[6]  </a:t>
             </a:r>
             <a:r>
               <a:rPr sz="1400" b="0" i="0" u="none">
@@ -8800,7 +8567,7 @@
                 </a:solidFill>
                 <a:latin typeface="Times New Roman"/>
               </a:rPr>
-              <a:t>X. Feng, M. Ouyang, X. Liu, L. Lu, Y. Xia, and X. He, “Thermal runaway mechanism of lithium ion battery for electric vehicles: A review,” Energy Storage Mater., vol. 10, pp. 246–267, Jan. 2018, doi: 10.1016/j.ensm.2017.05.013.</a:t>
+              <a:t>Z. Sun et al., “An online data-driven fault diagnosis and thermal runaway early warning for electric vehicle batteries,” IEEE Trans. Power Electron., vol. 37, no. 10, pp. 12636–12646, Oct. 2022, doi: 10.1109/TPEL.2022.3173038.</a:t>
             </a:r>
           </a:p>
           <a:p>
@@ -8820,7 +8587,7 @@
                 </a:solidFill>
                 <a:latin typeface="Times New Roman"/>
               </a:rPr>
-              <a:t>[2]  </a:t>
+              <a:t>[7]  </a:t>
             </a:r>
             <a:r>
               <a:rPr sz="1400" b="0" i="0" u="none">
@@ -8829,7 +8596,7 @@
                 </a:solidFill>
                 <a:latin typeface="Times New Roman"/>
               </a:rPr>
-              <a:t>H. Rahimi-Eichi, U. Ojha, F. Baronti, and M.-Y. Chow, “Battery management system: An overview of its application in the smart grid and electric vehicles,” IEEE Ind. Electron. Mag., vol. 7, no. 2, pp. 4–16, Jun. 2013, doi: 10.1109/MIE.2013.2250351.</a:t>
+              <a:t>O. Ojo, H. Lang, Y. Kim, X. Hu, B. Mu, and X. Lin, “A neural network based method for thermal fault detection in lithium-ion batteries,” IEEE Trans. Ind. Electron., vol. 68, no. 5, pp. 4068–4078, May 2021, doi: 10.1109/TIE.2020.2984980.</a:t>
             </a:r>
           </a:p>
           <a:p>
@@ -8849,7 +8616,7 @@
                 </a:solidFill>
                 <a:latin typeface="Times New Roman"/>
               </a:rPr>
-              <a:t>[3]  </a:t>
+              <a:t>[8]  </a:t>
             </a:r>
             <a:r>
               <a:rPr sz="1400" b="0" i="0" u="none">
@@ -8858,7 +8625,7 @@
                 </a:solidFill>
                 <a:latin typeface="Times New Roman"/>
               </a:rPr>
-              <a:t>B. Xu, L. Kong, G. Wen, and M. G. Pecht, “Protection devices in commercial 18650 lithium-ion batteries,” IEEE Access, vol. 9, pp. 66687–66695, 2021, doi: 10.1109/ACCESS.2021.3075972.</a:t>
+              <a:t>Q. Chen, Y. He, N. Fang, and G. Yu, “A combined data-driven and model-based algorithm for accurate battery thermal runaway warning,” Sensors, vol. 24, no. 15, Art. no. 4964, Jul. 2024, doi: 10.3390/s24154964.</a:t>
             </a:r>
           </a:p>
           <a:p>
@@ -8878,7 +8645,7 @@
                 </a:solidFill>
                 <a:latin typeface="Times New Roman"/>
               </a:rPr>
-              <a:t>[4]  </a:t>
+              <a:t>[9]  </a:t>
             </a:r>
             <a:r>
               <a:rPr sz="1400" b="0" i="0" u="none">
@@ -8887,7 +8654,7 @@
                 </a:solidFill>
                 <a:latin typeface="Times New Roman"/>
               </a:rPr>
-              <a:t>X. Hu, K. Zhang, K. Liu, X. Lin, S. Dey, and S. Onori, “Advanced fault diagnosis for lithium-ion battery systems: A review of fault mechanisms, fault features, and diagnosis procedures,” IEEE Ind. Electron. Mag., vol. 14, no. 3, pp. 65–91, Sep. 2020, doi: 10.1109/MIE.2020.2964814.</a:t>
+              <a:t>X. Lin et al., “Online parameterization of lumped thermal dynamics in cylindrical lithium ion batteries for core temperature estimation and health monitoring,” IEEE Trans. Control Syst. Technol., vol. 21, no. 5, pp. 1745–1755, Sep. 2013, doi: 10.1109/TCST.2012.2217143.</a:t>
             </a:r>
           </a:p>
           <a:p>
@@ -8907,7 +8674,7 @@
                 </a:solidFill>
                 <a:latin typeface="Times New Roman"/>
               </a:rPr>
-              <a:t>[5]  </a:t>
+              <a:t>[10]  </a:t>
             </a:r>
             <a:r>
               <a:rPr sz="1400" b="0" i="0" u="none">
@@ -8916,7 +8683,7 @@
                 </a:solidFill>
                 <a:latin typeface="Times New Roman"/>
               </a:rPr>
-              <a:t>X. Zhang, S. Chen, J. Zhu, and Y. Gao, “A critical review of thermal runaway prediction and early-warning methods for lithium-ion batteries,” Energy Mater. Adv., vol. 4, Art. no. 0008, 2023, doi: 10.34133/energymatadv.0008.</a:t>
+              <a:t>A. Adhikaree, T. Kim, J. Vagdoda, A. Ochoa, P. J. Hernandez, and Y. Lee, “Cloud-based battery condition monitoring platform for large-scale lithium-ion battery energy storage systems using internet-of-things (IoT),” in Proc. IEEE Energy Convers. Congr. Expo. (ECCE), 2017, pp. 1004–1009, doi: 10.1109/ECCE.2017.8095896.</a:t>
             </a:r>
           </a:p>
         </p:txBody>
@@ -8971,41 +8738,6 @@
         </p:nvSpPr>
         <p:spPr>
           <a:xfrm>
-            <a:off x="1188720" y="384048"/>
-            <a:ext cx="9814255" cy="548640"/>
-          </a:xfrm>
-          <a:prstGeom prst="rect">
-            <a:avLst/>
-          </a:prstGeom>
-          <a:noFill/>
-        </p:spPr>
-        <p:txBody>
-          <a:bodyPr wrap="square" lIns="0" rIns="0" tIns="0" bIns="0">
-            <a:noAutofit/>
-          </a:bodyPr>
-          <a:lstStyle/>
-          <a:p>
-            <a:pPr algn="ctr"/>
-            <a:r>
-              <a:rPr sz="2400" b="1" i="0" u="sng">
-                <a:solidFill>
-                  <a:srgbClr val="000000"/>
-                </a:solidFill>
-                <a:latin typeface="Times New Roman"/>
-              </a:rPr>
-              <a:t>References (contd.)</a:t>
-            </a:r>
-          </a:p>
-        </p:txBody>
-      </p:sp>
-      <p:sp>
-        <p:nvSpPr>
-          <p:cNvPr id="4" name="TextBox 3"/>
-          <p:cNvSpPr txBox="1"/>
-          <p:nvPr/>
-        </p:nvSpPr>
-        <p:spPr>
-          <a:xfrm>
             <a:off x="929944" y="6355080"/>
             <a:ext cx="2286000" cy="292608"/>
           </a:xfrm>
@@ -9034,7 +8766,7 @@
       </p:sp>
       <p:sp>
         <p:nvSpPr>
-          <p:cNvPr id="5" name="TextBox 4"/>
+          <p:cNvPr id="4" name="TextBox 3"/>
           <p:cNvSpPr txBox="1"/>
           <p:nvPr/>
         </p:nvSpPr>
@@ -9069,7 +8801,7 @@
       </p:sp>
       <p:sp>
         <p:nvSpPr>
-          <p:cNvPr id="6" name="TextBox 5"/>
+          <p:cNvPr id="5" name="TextBox 4"/>
           <p:cNvSpPr txBox="1"/>
           <p:nvPr/>
         </p:nvSpPr>
@@ -9098,320 +8830,6 @@
                 <a:latin typeface="Calibri"/>
               </a:rPr>
               <a:t>16</a:t>
-            </a:r>
-          </a:p>
-        </p:txBody>
-      </p:sp>
-      <p:sp>
-        <p:nvSpPr>
-          <p:cNvPr id="7" name="TextBox 6"/>
-          <p:cNvSpPr txBox="1"/>
-          <p:nvPr/>
-        </p:nvSpPr>
-        <p:spPr>
-          <a:xfrm>
-            <a:off x="1168603" y="1389888"/>
-            <a:ext cx="10195560" cy="4754879"/>
-          </a:xfrm>
-          <a:prstGeom prst="rect">
-            <a:avLst/>
-          </a:prstGeom>
-          <a:noFill/>
-        </p:spPr>
-        <p:txBody>
-          <a:bodyPr wrap="square" lIns="0" rIns="0" tIns="0" bIns="0">
-            <a:noAutofit/>
-          </a:bodyPr>
-          <a:lstStyle/>
-          <a:p>
-            <a:pPr marL="384048" indent="-384048">
-              <a:lnSpc>
-                <a:spcPct val="110000"/>
-              </a:lnSpc>
-              <a:spcAft>
-                <a:spcPts val="2000"/>
-              </a:spcAft>
-              <a:buNone/>
-            </a:pPr>
-            <a:r>
-              <a:rPr sz="1400" b="0" i="0" u="none">
-                <a:solidFill>
-                  <a:srgbClr val="000000"/>
-                </a:solidFill>
-                <a:latin typeface="Times New Roman"/>
-              </a:rPr>
-              <a:t>[6]  </a:t>
-            </a:r>
-            <a:r>
-              <a:rPr sz="1400" b="0" i="0" u="none">
-                <a:solidFill>
-                  <a:srgbClr val="000000"/>
-                </a:solidFill>
-                <a:latin typeface="Times New Roman"/>
-              </a:rPr>
-              <a:t>Z. Sun et al., “An online data-driven fault diagnosis and thermal runaway early warning for electric vehicle batteries,” IEEE Trans. Power Electron., vol. 37, no. 10, pp. 12636–12646, Oct. 2022, doi: 10.1109/TPEL.2022.3173038.</a:t>
-            </a:r>
-          </a:p>
-          <a:p>
-            <a:pPr marL="384048" indent="-384048">
-              <a:lnSpc>
-                <a:spcPct val="110000"/>
-              </a:lnSpc>
-              <a:spcAft>
-                <a:spcPts val="2000"/>
-              </a:spcAft>
-              <a:buNone/>
-            </a:pPr>
-            <a:r>
-              <a:rPr sz="1400" b="0" i="0" u="none">
-                <a:solidFill>
-                  <a:srgbClr val="000000"/>
-                </a:solidFill>
-                <a:latin typeface="Times New Roman"/>
-              </a:rPr>
-              <a:t>[7]  </a:t>
-            </a:r>
-            <a:r>
-              <a:rPr sz="1400" b="0" i="0" u="none">
-                <a:solidFill>
-                  <a:srgbClr val="000000"/>
-                </a:solidFill>
-                <a:latin typeface="Times New Roman"/>
-              </a:rPr>
-              <a:t>O. Ojo, H. Lang, Y. Kim, X. Hu, B. Mu, and X. Lin, “A neural network based method for thermal fault detection in lithium-ion batteries,” IEEE Trans. Ind. Electron., vol. 68, no. 5, pp. 4068–4078, May 2021, doi: 10.1109/TIE.2020.2984980.</a:t>
-            </a:r>
-          </a:p>
-          <a:p>
-            <a:pPr marL="384048" indent="-384048">
-              <a:lnSpc>
-                <a:spcPct val="110000"/>
-              </a:lnSpc>
-              <a:spcAft>
-                <a:spcPts val="2000"/>
-              </a:spcAft>
-              <a:buNone/>
-            </a:pPr>
-            <a:r>
-              <a:rPr sz="1400" b="0" i="0" u="none">
-                <a:solidFill>
-                  <a:srgbClr val="000000"/>
-                </a:solidFill>
-                <a:latin typeface="Times New Roman"/>
-              </a:rPr>
-              <a:t>[8]  </a:t>
-            </a:r>
-            <a:r>
-              <a:rPr sz="1400" b="0" i="0" u="none">
-                <a:solidFill>
-                  <a:srgbClr val="000000"/>
-                </a:solidFill>
-                <a:latin typeface="Times New Roman"/>
-              </a:rPr>
-              <a:t>Q. Chen, Y. He, N. Fang, and G. Yu, “A combined data-driven and model-based algorithm for accurate battery thermal runaway warning,” Sensors, vol. 24, no. 15, Art. no. 4964, Jul. 2024, doi: 10.3390/s24154964.</a:t>
-            </a:r>
-          </a:p>
-          <a:p>
-            <a:pPr marL="384048" indent="-384048">
-              <a:lnSpc>
-                <a:spcPct val="110000"/>
-              </a:lnSpc>
-              <a:spcAft>
-                <a:spcPts val="2000"/>
-              </a:spcAft>
-              <a:buNone/>
-            </a:pPr>
-            <a:r>
-              <a:rPr sz="1400" b="0" i="0" u="none">
-                <a:solidFill>
-                  <a:srgbClr val="000000"/>
-                </a:solidFill>
-                <a:latin typeface="Times New Roman"/>
-              </a:rPr>
-              <a:t>[9]  </a:t>
-            </a:r>
-            <a:r>
-              <a:rPr sz="1400" b="0" i="0" u="none">
-                <a:solidFill>
-                  <a:srgbClr val="000000"/>
-                </a:solidFill>
-                <a:latin typeface="Times New Roman"/>
-              </a:rPr>
-              <a:t>X. Lin et al., “Online parameterization of lumped thermal dynamics in cylindrical lithium ion batteries for core temperature estimation and health monitoring,” IEEE Trans. Control Syst. Technol., vol. 21, no. 5, pp. 1745–1755, Sep. 2013, doi: 10.1109/TCST.2012.2217143.</a:t>
-            </a:r>
-          </a:p>
-          <a:p>
-            <a:pPr marL="384048" indent="-384048">
-              <a:lnSpc>
-                <a:spcPct val="110000"/>
-              </a:lnSpc>
-              <a:spcAft>
-                <a:spcPts val="2000"/>
-              </a:spcAft>
-              <a:buNone/>
-            </a:pPr>
-            <a:r>
-              <a:rPr sz="1400" b="0" i="0" u="none">
-                <a:solidFill>
-                  <a:srgbClr val="000000"/>
-                </a:solidFill>
-                <a:latin typeface="Times New Roman"/>
-              </a:rPr>
-              <a:t>[10]  </a:t>
-            </a:r>
-            <a:r>
-              <a:rPr sz="1400" b="0" i="0" u="none">
-                <a:solidFill>
-                  <a:srgbClr val="000000"/>
-                </a:solidFill>
-                <a:latin typeface="Times New Roman"/>
-              </a:rPr>
-              <a:t>A. Adhikaree, T. Kim, J. Vagdoda, A. Ochoa, P. J. Hernandez, and Y. Lee, “Cloud-based battery condition monitoring platform for large-scale lithium-ion battery energy storage systems using internet-of-things (IoT),” in Proc. IEEE Energy Convers. Congr. Expo. (ECCE), 2017, pp. 1004–1009, doi: 10.1109/ECCE.2017.8095896.</a:t>
-            </a:r>
-          </a:p>
-        </p:txBody>
-      </p:sp>
-    </p:spTree>
-  </p:cSld>
-  <p:clrMapOvr>
-    <a:masterClrMapping/>
-  </p:clrMapOvr>
-</p:sld>
-</file>
-
-<file path=ppt/slides/slide17.xml><?xml version="1.0" encoding="utf-8"?>
-<p:sld xmlns:a="http://schemas.openxmlformats.org/drawingml/2006/main" xmlns:p="http://schemas.openxmlformats.org/presentationml/2006/main" xmlns:r="http://schemas.openxmlformats.org/officeDocument/2006/relationships">
-  <p:cSld>
-    <p:spTree>
-      <p:nvGrpSpPr>
-        <p:cNvPr id="1" name=""/>
-        <p:cNvGrpSpPr/>
-        <p:nvPr/>
-      </p:nvGrpSpPr>
-      <p:grpSpPr/>
-      <p:pic>
-        <p:nvPicPr>
-          <p:cNvPr id="2" name="Picture 1" descr="logo.png"/>
-          <p:cNvPicPr>
-            <a:picLocks noChangeAspect="1"/>
-          </p:cNvPicPr>
-          <p:nvPr/>
-        </p:nvPicPr>
-        <p:blipFill>
-          <a:blip r:embed="rId2"/>
-          <a:stretch>
-            <a:fillRect/>
-          </a:stretch>
-        </p:blipFill>
-        <p:spPr>
-          <a:xfrm>
-            <a:off x="286207" y="109728"/>
-            <a:ext cx="646480" cy="950976"/>
-          </a:xfrm>
-          <a:prstGeom prst="rect">
-            <a:avLst/>
-          </a:prstGeom>
-        </p:spPr>
-      </p:pic>
-      <p:sp>
-        <p:nvSpPr>
-          <p:cNvPr id="3" name="TextBox 2"/>
-          <p:cNvSpPr txBox="1"/>
-          <p:nvPr/>
-        </p:nvSpPr>
-        <p:spPr>
-          <a:xfrm>
-            <a:off x="929944" y="6355080"/>
-            <a:ext cx="2286000" cy="292608"/>
-          </a:xfrm>
-          <a:prstGeom prst="rect">
-            <a:avLst/>
-          </a:prstGeom>
-          <a:noFill/>
-        </p:spPr>
-        <p:txBody>
-          <a:bodyPr wrap="square" lIns="0" rIns="0" tIns="0" bIns="0">
-            <a:noAutofit/>
-          </a:bodyPr>
-          <a:lstStyle/>
-          <a:p>
-            <a:r>
-              <a:rPr sz="1200" b="0" i="0" u="none">
-                <a:solidFill>
-                  <a:srgbClr val="898989"/>
-                </a:solidFill>
-                <a:latin typeface="Calibri"/>
-              </a:rPr>
-              <a:t>29-09-2026</a:t>
-            </a:r>
-          </a:p>
-        </p:txBody>
-      </p:sp>
-      <p:sp>
-        <p:nvSpPr>
-          <p:cNvPr id="4" name="TextBox 3"/>
-          <p:cNvSpPr txBox="1"/>
-          <p:nvPr/>
-        </p:nvSpPr>
-        <p:spPr>
-          <a:xfrm>
-            <a:off x="3931920" y="6355080"/>
-            <a:ext cx="4297680" cy="292608"/>
-          </a:xfrm>
-          <a:prstGeom prst="rect">
-            <a:avLst/>
-          </a:prstGeom>
-          <a:noFill/>
-        </p:spPr>
-        <p:txBody>
-          <a:bodyPr wrap="square" lIns="0" rIns="0" tIns="0" bIns="0">
-            <a:noAutofit/>
-          </a:bodyPr>
-          <a:lstStyle/>
-          <a:p>
-            <a:pPr algn="ctr"/>
-            <a:r>
-              <a:rPr sz="1200" b="0" i="0" u="none">
-                <a:solidFill>
-                  <a:srgbClr val="898989"/>
-                </a:solidFill>
-                <a:latin typeface="Calibri"/>
-              </a:rPr>
-              <a:t>First Review-2026-27</a:t>
-            </a:r>
-          </a:p>
-        </p:txBody>
-      </p:sp>
-      <p:sp>
-        <p:nvSpPr>
-          <p:cNvPr id="5" name="TextBox 4"/>
-          <p:cNvSpPr txBox="1"/>
-          <p:nvPr/>
-        </p:nvSpPr>
-        <p:spPr>
-          <a:xfrm>
-            <a:off x="10058400" y="6355080"/>
-            <a:ext cx="1204264" cy="292608"/>
-          </a:xfrm>
-          <a:prstGeom prst="rect">
-            <a:avLst/>
-          </a:prstGeom>
-          <a:noFill/>
-        </p:spPr>
-        <p:txBody>
-          <a:bodyPr wrap="square" lIns="0" rIns="0" tIns="0" bIns="0">
-            <a:noAutofit/>
-          </a:bodyPr>
-          <a:lstStyle/>
-          <a:p>
-            <a:pPr algn="r"/>
-            <a:r>
-              <a:rPr sz="1200" b="0" i="0" u="none">
-                <a:solidFill>
-                  <a:srgbClr val="898989"/>
-                </a:solidFill>
-                <a:latin typeface="Calibri"/>
-              </a:rPr>
-              <a:t>17</a:t>
             </a:r>
           </a:p>
         </p:txBody>
@@ -9935,7 +9353,7 @@
                 </a:solidFill>
                 <a:latin typeface="Times New Roman"/>
               </a:rPr>
-              <a:t>Individual Contribution</a:t>
+              <a:t>Project Timeline</a:t>
             </a:r>
           </a:p>
           <a:p>
@@ -9956,35 +9374,6 @@
                 <a:latin typeface="Times New Roman"/>
               </a:rPr>
               <a:t>10.  </a:t>
-            </a:r>
-            <a:r>
-              <a:rPr sz="1700" b="0" i="0" u="none">
-                <a:solidFill>
-                  <a:srgbClr val="000000"/>
-                </a:solidFill>
-                <a:latin typeface="Times New Roman"/>
-              </a:rPr>
-              <a:t>Project Timeline</a:t>
-            </a:r>
-          </a:p>
-          <a:p>
-            <a:pPr marL="384048" indent="-384048">
-              <a:lnSpc>
-                <a:spcPct val="110000"/>
-              </a:lnSpc>
-              <a:spcAft>
-                <a:spcPts val="1300"/>
-              </a:spcAft>
-              <a:buNone/>
-            </a:pPr>
-            <a:r>
-              <a:rPr sz="1700" b="0" i="0" u="none">
-                <a:solidFill>
-                  <a:srgbClr val="000000"/>
-                </a:solidFill>
-                <a:latin typeface="Times New Roman"/>
-              </a:rPr>
-              <a:t>11.  </a:t>
             </a:r>
             <a:r>
               <a:rPr sz="1700" b="0" i="0" u="none">

</xml_diff>

<commit_message>
docs: show the predictive layer in the first-review deck
The Methodology diagram gains a Predict step, and the abstract, objectives,
hardware table, timeline, block and schematic diagrams and speaker notes
now describe the thermal model and the fifth (ambient) NTC.
</commit_message>
<xml_diff>
--- a/docs/reviews/first-review/Predictive_BMS_First_Review.pptx
+++ b/docs/reviews/first-review/Predictive_BMS_First_Review.pptx
@@ -522,12 +522,12 @@
           </a:p>
           <a:p>
             <a:r>
-              <a:t>battery management system for a small lithium-ion pack that watches how fast the</a:t>
-            </a:r>
-          </a:p>
-          <a:p>
-            <a:r>
-              <a:t>cells are warming up, not only how hot they are. Since the zeroth review I have</a:t>
+              <a:t>battery management system for a small lithium-ion pack that predicts how fast each</a:t>
+            </a:r>
+          </a:p>
+          <a:p>
+            <a:r>
+              <a:t>cell should be warming up, and acts when a cell heats faster than its current explains. Since the zeroth review I have</a:t>
             </a:r>
           </a:p>
           <a:p>
@@ -627,7 +627,12 @@
           </a:p>
           <a:p>
             <a:r>
-              <a:t>current and four thermistors for temperature, and it drives two relays that connect the</a:t>
+              <a:t>current and five thermistors for temperature, one on each cell and one in the air, and</a:t>
+            </a:r>
+          </a:p>
+          <a:p>
+            <a:r>
+              <a:t>it drives two relays that connect the</a:t>
             </a:r>
           </a:p>
           <a:p>
@@ -802,7 +807,7 @@
           </a:p>
           <a:p>
             <a:r>
-              <a:t>INA226 for current and the four thermistors. The relay module gives the separate charge</a:t>
+              <a:t>INA226 for current and the five thermistors. The relay module gives the separate charge</a:t>
             </a:r>
           </a:p>
           <a:p>
@@ -1282,7 +1287,7 @@
           </a:p>
           <a:p>
             <a:r>
-              <a:t>protects the cells on its own, and an ESP32 layer that watches the temperature trend.</a:t>
+              <a:t>protects the cells on its own, and an ESP32 layer that predicts how each cell should heat.</a:t>
             </a:r>
           </a:p>
           <a:p>
@@ -1827,32 +1832,57 @@
           </a:p>
           <a:p>
             <a:r>
-              <a:t>the pack current and the four temperatures, removes noise with a median filter and a</a:t>
-            </a:r>
-          </a:p>
-          <a:p>
-            <a:r>
-              <a:t>ten-second low-pass filter, and then works out the rate of temperature rise by fitting a</a:t>
-            </a:r>
-          </a:p>
-          <a:p>
-            <a:r>
-              <a:t>straight line over the last thirty seconds. Before trusting any reading it checks that</a:t>
-            </a:r>
-          </a:p>
-          <a:p>
-            <a:r>
-              <a:t>the sensors are plausible. Then it compares everything with the trip limits and the</a:t>
-            </a:r>
-          </a:p>
-          <a:p>
-            <a:r>
-              <a:t>warning limits. A trip opens only the relay for the unsafe direction and stays latched</a:t>
-            </a:r>
-          </a:p>
-          <a:p>
-            <a:r>
-              <a:t>until a manual reset.</a:t>
+              <a:t>the pack current, the four cell temperatures and the air temperature, removes noise with</a:t>
+            </a:r>
+          </a:p>
+          <a:p>
+            <a:r>
+              <a:t>a median filter and a ten-second low-pass filter, and works out the rate of temperature</a:t>
+            </a:r>
+          </a:p>
+          <a:p>
+            <a:r>
+              <a:t>rise by fitting a straight line over the last thirty seconds. Then it predicts. A thermal</a:t>
+            </a:r>
+          </a:p>
+          <a:p>
+            <a:r>
+              <a:t>model of each cell, with a Kalman filter, estimates the core temperature and the abnormal</a:t>
+            </a:r>
+          </a:p>
+          <a:p>
+            <a:r>
+              <a:t>heat in watts: heat the current cannot explain, the early sign of a fault. Every ten</a:t>
+            </a:r>
+          </a:p>
+          <a:p>
+            <a:r>
+              <a:t>seconds it forecasts each cell's temperature five minutes ahead, and when that time comes</a:t>
+            </a:r>
+          </a:p>
+          <a:p>
+            <a:r>
+              <a:t>it checks the forecast against the real reading. It also compares the cells with each</a:t>
+            </a:r>
+          </a:p>
+          <a:p>
+            <a:r>
+              <a:t>other, checks each cell's self-discharge at rest, and works out the safe current.</a:t>
+            </a:r>
+          </a:p>
+          <a:p>
+            <a:r>
+              <a:t>Before trusting any reading it checks that the sensors are plausible, then compares</a:t>
+            </a:r>
+          </a:p>
+          <a:p>
+            <a:r>
+              <a:t>everything with the trip and warning limits. A trip opens only the relay for the unsafe</a:t>
+            </a:r>
+          </a:p>
+          <a:p>
+            <a:r>
+              <a:t>direction and stays latched until a manual reset.</a:t>
             </a:r>
           </a:p>
         </p:txBody>
@@ -6266,8 +6296,8 @@
         </p:blipFill>
         <p:spPr>
           <a:xfrm>
-            <a:off x="365760" y="2943590"/>
-            <a:ext cx="8412480" cy="2525298"/>
+            <a:off x="365760" y="2946306"/>
+            <a:ext cx="8412480" cy="2519867"/>
           </a:xfrm>
           <a:prstGeom prst="rect">
             <a:avLst/>
@@ -6778,7 +6808,7 @@
                           </a:solidFill>
                           <a:latin typeface="Times New Roman"/>
                         </a:rPr>
-                        <a:t>Sensing, dT/dt, relay control and Wi-Fi</a:t>
+                        <a:t>Sensing, thermal prediction, relays, Wi-Fi</a:t>
                       </a:r>
                     </a:p>
                   </a:txBody>
@@ -7110,7 +7140,7 @@
                           </a:solidFill>
                           <a:latin typeface="Times New Roman"/>
                         </a:rPr>
-                        <a:t>4 × NTC 10 kΩ B3950</a:t>
+                        <a:t>5 × NTC 10 kΩ B3950</a:t>
                       </a:r>
                     </a:p>
                   </a:txBody>
@@ -7133,7 +7163,7 @@
                           </a:solidFill>
                           <a:latin typeface="Times New Roman"/>
                         </a:rPr>
-                        <a:t>Temperature on each cell</a:t>
+                        <a:t>Temperature of each cell and of the air</a:t>
                       </a:r>
                     </a:p>
                   </a:txBody>
@@ -8560,7 +8590,7 @@
                           </a:solidFill>
                           <a:latin typeface="Times New Roman"/>
                         </a:rPr>
-                        <a:t>dT/dt Estimation &amp; Safety State Machine</a:t>
+                        <a:t>Thermal Prediction &amp; Safety State Machine</a:t>
                       </a:r>
                     </a:p>
                   </a:txBody>
@@ -11412,7 +11442,7 @@
                 </a:solidFill>
                 <a:latin typeface="Times New Roman"/>
               </a:rPr>
-              <a:t>A hardware BMS gives over-voltage, under-voltage, over-current and short-circuit protection. An ESP32 measures every cell voltage, the pack current and four cell temperatures, and works out how fast the temperature is rising.</a:t>
+              <a:t>A hardware BMS gives over-voltage, under-voltage, over-current and short-circuit protection. An ESP32 measures every cell voltage, the pack current and the cell and air temperatures, and uses a thermal model to predict how fast each cell should heat.</a:t>
             </a:r>
           </a:p>
           <a:p>
@@ -11433,7 +11463,7 @@
                 </a:solidFill>
                 <a:latin typeface="Times New Roman"/>
               </a:rPr>
-              <a:t>When a reading or the rate of rise crosses a limit, the ESP32 opens the charge or load relay and latches the fault. Readings are shown on a Wi-Fi dashboard that is not part of the safety chain.</a:t>
+              <a:t>When a cell heats faster than the current explains, or a reading crosses a limit, the ESP32 opens the charge or load relay and latches the fault. Readings are shown on a Wi-Fi dashboard that is not part of the safety chain.</a:t>
             </a:r>
           </a:p>
         </p:txBody>
@@ -14787,7 +14817,7 @@
                 </a:solidFill>
                 <a:latin typeface="Times New Roman"/>
               </a:rPr>
-              <a:t>To measure every cell voltage, the pack current and four cell temperatures accurately, using an ADS1115, an INA226 and NTC thermistors.</a:t>
+              <a:t>To measure every cell voltage, the pack current, four cell temperatures and the air temperature accurately, using an ADS1115, an INA226 and NTC thermistors.</a:t>
             </a:r>
           </a:p>
           <a:p>
@@ -14808,7 +14838,7 @@
                 </a:solidFill>
                 <a:latin typeface="Times New Roman"/>
               </a:rPr>
-              <a:t>To estimate the rate of temperature rise (dT/dt) in firmware and act on it before any fixed temperature limit is reached, with every trip latched.</a:t>
+              <a:t>To predict each cell's heating with a thermal model, and act on heating the current cannot explain before any fixed temperature limit is reached, with every trip latched.</a:t>
             </a:r>
           </a:p>
           <a:p>

</xml_diff>